<commit_message>
Added document upload (WIP) and fixed xml corruption for brochures
</commit_message>
<xml_diff>
--- a/templates/ekona_slides_template_new/ekona_slides_template_new.pptx
+++ b/templates/ekona_slides_template_new/ekona_slides_template_new.pptx
@@ -121,7 +121,7 @@
 <file path=ppt/revisionInfo.xml><?xml version="1.0" encoding="utf-8"?>
 <p1510:revInfo xmlns:a="http://schemas.openxmlformats.org/drawingml/2006/main" xmlns:r="http://schemas.openxmlformats.org/officeDocument/2006/relationships" xmlns:p1510="http://schemas.microsoft.com/office/powerpoint/2015/10/main">
   <p1510:revLst>
-    <p1510:client id="{EDFF173F-DF9C-D14E-964C-429E56C8376C}" v="1" dt="2025-08-13T18:27:27.059"/>
+    <p1510:client id="{EDFF173F-DF9C-D14E-964C-429E56C8376C}" v="7" dt="2025-08-18T19:51:33.294"/>
   </p1510:revLst>
 </p1510:revInfo>
 </file>
@@ -213,15 +213,6 @@
             <pc:sldLayoutMk cId="3074954578" sldId="2147483650"/>
           </pc:sldLayoutMkLst>
           <pc:spChg chg="mod">
-            <ac:chgData name="Sam Khalil" userId="82cd1ec2-6208-465b-9d4d-40ce8f0cbf96" providerId="ADAL" clId="{651B6F30-EC96-2340-AD4B-07A6B9855D0C}" dt="2025-07-17T09:54:09.708" v="670"/>
-            <ac:spMkLst>
-              <pc:docMk/>
-              <pc:sldMasterMk cId="2940896467" sldId="2147483648"/>
-              <pc:sldLayoutMk cId="3074954578" sldId="2147483650"/>
-              <ac:spMk id="2" creationId="{A5319A24-5E84-B92C-D93E-988EC46CF0CA}"/>
-            </ac:spMkLst>
-          </pc:spChg>
-          <pc:spChg chg="mod">
             <ac:chgData name="Sam Khalil" userId="82cd1ec2-6208-465b-9d4d-40ce8f0cbf96" providerId="ADAL" clId="{651B6F30-EC96-2340-AD4B-07A6B9855D0C}" dt="2025-07-21T08:06:13.638" v="2143" actId="20577"/>
             <ac:spMkLst>
               <pc:docMk/>
@@ -265,24 +256,6 @@
             <pc:sldMasterMk cId="2940896467" sldId="2147483648"/>
             <pc:sldLayoutMk cId="996161729" sldId="2147483666"/>
           </pc:sldLayoutMkLst>
-          <pc:spChg chg="mod">
-            <ac:chgData name="Sam Khalil" userId="82cd1ec2-6208-465b-9d4d-40ce8f0cbf96" providerId="ADAL" clId="{651B6F30-EC96-2340-AD4B-07A6B9855D0C}" dt="2025-07-17T09:54:04.067" v="669"/>
-            <ac:spMkLst>
-              <pc:docMk/>
-              <pc:sldMasterMk cId="2940896467" sldId="2147483648"/>
-              <pc:sldLayoutMk cId="996161729" sldId="2147483666"/>
-              <ac:spMk id="2" creationId="{3CD97974-B93C-4C96-B3F6-F69E3D6DE6CA}"/>
-            </ac:spMkLst>
-          </pc:spChg>
-          <pc:spChg chg="mod">
-            <ac:chgData name="Sam Khalil" userId="82cd1ec2-6208-465b-9d4d-40ce8f0cbf96" providerId="ADAL" clId="{651B6F30-EC96-2340-AD4B-07A6B9855D0C}" dt="2025-07-17T09:52:50.624" v="469" actId="20577"/>
-            <ac:spMkLst>
-              <pc:docMk/>
-              <pc:sldMasterMk cId="2940896467" sldId="2147483648"/>
-              <pc:sldLayoutMk cId="996161729" sldId="2147483666"/>
-              <ac:spMk id="15" creationId="{6AB10746-1273-02BA-C457-602DEDA7F5F4}"/>
-            </ac:spMkLst>
-          </pc:spChg>
         </pc:sldLayoutChg>
         <pc:sldLayoutChg chg="addSp modSp mod">
           <pc:chgData name="Sam Khalil" userId="82cd1ec2-6208-465b-9d4d-40ce8f0cbf96" providerId="ADAL" clId="{651B6F30-EC96-2340-AD4B-07A6B9855D0C}" dt="2025-07-21T08:05:08.740" v="2106" actId="1076"/>
@@ -291,15 +264,6 @@
             <pc:sldMasterMk cId="2940896467" sldId="2147483648"/>
             <pc:sldLayoutMk cId="3100185760" sldId="2147483667"/>
           </pc:sldLayoutMkLst>
-          <pc:spChg chg="mod">
-            <ac:chgData name="Sam Khalil" userId="82cd1ec2-6208-465b-9d4d-40ce8f0cbf96" providerId="ADAL" clId="{651B6F30-EC96-2340-AD4B-07A6B9855D0C}" dt="2025-07-17T09:54:02.244" v="668"/>
-            <ac:spMkLst>
-              <pc:docMk/>
-              <pc:sldMasterMk cId="2940896467" sldId="2147483648"/>
-              <pc:sldLayoutMk cId="3100185760" sldId="2147483667"/>
-              <ac:spMk id="2" creationId="{3CD97974-B93C-4C96-B3F6-F69E3D6DE6CA}"/>
-            </ac:spMkLst>
-          </pc:spChg>
           <pc:spChg chg="mod">
             <ac:chgData name="Sam Khalil" userId="82cd1ec2-6208-465b-9d4d-40ce8f0cbf96" providerId="ADAL" clId="{651B6F30-EC96-2340-AD4B-07A6B9855D0C}" dt="2025-07-21T08:05:08.740" v="2106" actId="1076"/>
             <ac:spMkLst>
@@ -326,24 +290,6 @@
             <pc:sldMasterMk cId="2940896467" sldId="2147483648"/>
             <pc:sldLayoutMk cId="2561689790" sldId="2147483668"/>
           </pc:sldLayoutMkLst>
-          <pc:spChg chg="mod">
-            <ac:chgData name="Sam Khalil" userId="82cd1ec2-6208-465b-9d4d-40ce8f0cbf96" providerId="ADAL" clId="{651B6F30-EC96-2340-AD4B-07A6B9855D0C}" dt="2025-07-17T09:53:58.655" v="667" actId="20577"/>
-            <ac:spMkLst>
-              <pc:docMk/>
-              <pc:sldMasterMk cId="2940896467" sldId="2147483648"/>
-              <pc:sldLayoutMk cId="2561689790" sldId="2147483668"/>
-              <ac:spMk id="2" creationId="{3CD97974-B93C-4C96-B3F6-F69E3D6DE6CA}"/>
-            </ac:spMkLst>
-          </pc:spChg>
-          <pc:spChg chg="mod">
-            <ac:chgData name="Sam Khalil" userId="82cd1ec2-6208-465b-9d4d-40ce8f0cbf96" providerId="ADAL" clId="{651B6F30-EC96-2340-AD4B-07A6B9855D0C}" dt="2025-07-17T09:54:44.817" v="787" actId="20577"/>
-            <ac:spMkLst>
-              <pc:docMk/>
-              <pc:sldMasterMk cId="2940896467" sldId="2147483648"/>
-              <pc:sldLayoutMk cId="2561689790" sldId="2147483668"/>
-              <ac:spMk id="15" creationId="{5A63EF3E-EE23-DD43-1AAF-5ED1F44A28DD}"/>
-            </ac:spMkLst>
-          </pc:spChg>
         </pc:sldLayoutChg>
         <pc:sldLayoutChg chg="del">
           <pc:chgData name="Sam Khalil" userId="82cd1ec2-6208-465b-9d4d-40ce8f0cbf96" providerId="ADAL" clId="{651B6F30-EC96-2340-AD4B-07A6B9855D0C}" dt="2025-07-16T20:03:04.043" v="1" actId="2696"/>
@@ -360,42 +306,6 @@
             <pc:sldMasterMk cId="2940896467" sldId="2147483648"/>
             <pc:sldLayoutMk cId="976521419" sldId="2147483671"/>
           </pc:sldLayoutMkLst>
-          <pc:spChg chg="add mod">
-            <ac:chgData name="Sam Khalil" userId="82cd1ec2-6208-465b-9d4d-40ce8f0cbf96" providerId="ADAL" clId="{651B6F30-EC96-2340-AD4B-07A6B9855D0C}" dt="2025-07-17T09:03:56.085" v="152" actId="962"/>
-            <ac:spMkLst>
-              <pc:docMk/>
-              <pc:sldMasterMk cId="2940896467" sldId="2147483648"/>
-              <pc:sldLayoutMk cId="976521419" sldId="2147483671"/>
-              <ac:spMk id="2" creationId="{451BA699-B22C-5269-513E-35DC959DE690}"/>
-            </ac:spMkLst>
-          </pc:spChg>
-          <pc:spChg chg="add mod">
-            <ac:chgData name="Sam Khalil" userId="82cd1ec2-6208-465b-9d4d-40ce8f0cbf96" providerId="ADAL" clId="{651B6F30-EC96-2340-AD4B-07A6B9855D0C}" dt="2025-07-17T09:51:08.809" v="311" actId="1076"/>
-            <ac:spMkLst>
-              <pc:docMk/>
-              <pc:sldMasterMk cId="2940896467" sldId="2147483648"/>
-              <pc:sldLayoutMk cId="976521419" sldId="2147483671"/>
-              <ac:spMk id="5" creationId="{CBE66CB9-C849-3A55-3368-6C1666C50D4F}"/>
-            </ac:spMkLst>
-          </pc:spChg>
-          <pc:spChg chg="add mod">
-            <ac:chgData name="Sam Khalil" userId="82cd1ec2-6208-465b-9d4d-40ce8f0cbf96" providerId="ADAL" clId="{651B6F30-EC96-2340-AD4B-07A6B9855D0C}" dt="2025-07-17T09:51:24.028" v="341" actId="20577"/>
-            <ac:spMkLst>
-              <pc:docMk/>
-              <pc:sldMasterMk cId="2940896467" sldId="2147483648"/>
-              <pc:sldLayoutMk cId="976521419" sldId="2147483671"/>
-              <ac:spMk id="8" creationId="{BFDDA68F-3F01-2EF4-5F5F-2DBCD3313533}"/>
-            </ac:spMkLst>
-          </pc:spChg>
-          <pc:spChg chg="add mod">
-            <ac:chgData name="Sam Khalil" userId="82cd1ec2-6208-465b-9d4d-40ce8f0cbf96" providerId="ADAL" clId="{651B6F30-EC96-2340-AD4B-07A6B9855D0C}" dt="2025-07-17T09:51:38.008" v="384" actId="20577"/>
-            <ac:spMkLst>
-              <pc:docMk/>
-              <pc:sldMasterMk cId="2940896467" sldId="2147483648"/>
-              <pc:sldLayoutMk cId="976521419" sldId="2147483671"/>
-              <ac:spMk id="9" creationId="{755D5765-4853-2CD1-FD28-234442F507BD}"/>
-            </ac:spMkLst>
-          </pc:spChg>
         </pc:sldLayoutChg>
         <pc:sldLayoutChg chg="addSp delSp modSp mod ord">
           <pc:chgData name="Sam Khalil" userId="82cd1ec2-6208-465b-9d4d-40ce8f0cbf96" providerId="ADAL" clId="{651B6F30-EC96-2340-AD4B-07A6B9855D0C}" dt="2025-07-21T08:09:17.134" v="2468" actId="207"/>
@@ -734,15 +644,6 @@
             <pc:sldMasterMk cId="2940896467" sldId="2147483648"/>
             <pc:sldLayoutMk cId="1049941252" sldId="2147483675"/>
           </pc:sldLayoutMkLst>
-          <pc:spChg chg="mod">
-            <ac:chgData name="Sam Khalil" userId="82cd1ec2-6208-465b-9d4d-40ce8f0cbf96" providerId="ADAL" clId="{651B6F30-EC96-2340-AD4B-07A6B9855D0C}" dt="2025-07-17T11:14:31.169" v="972"/>
-            <ac:spMkLst>
-              <pc:docMk/>
-              <pc:sldMasterMk cId="2940896467" sldId="2147483648"/>
-              <pc:sldLayoutMk cId="1049941252" sldId="2147483675"/>
-              <ac:spMk id="2" creationId="{3CD97974-B93C-4C96-B3F6-F69E3D6DE6CA}"/>
-            </ac:spMkLst>
-          </pc:spChg>
           <pc:spChg chg="add mod">
             <ac:chgData name="Sam Khalil" userId="82cd1ec2-6208-465b-9d4d-40ce8f0cbf96" providerId="ADAL" clId="{651B6F30-EC96-2340-AD4B-07A6B9855D0C}" dt="2025-07-21T08:06:45.805" v="2167" actId="1076"/>
             <ac:spMkLst>
@@ -894,15 +795,6 @@
             <pc:sldMasterMk cId="2940896467" sldId="2147483648"/>
             <pc:sldLayoutMk cId="3855316400" sldId="2147483677"/>
           </pc:sldLayoutMkLst>
-          <pc:spChg chg="mod">
-            <ac:chgData name="Sam Khalil" userId="82cd1ec2-6208-465b-9d4d-40ce8f0cbf96" providerId="ADAL" clId="{651B6F30-EC96-2340-AD4B-07A6B9855D0C}" dt="2025-07-17T22:12:58.955" v="1348" actId="962"/>
-            <ac:spMkLst>
-              <pc:docMk/>
-              <pc:sldMasterMk cId="2940896467" sldId="2147483648"/>
-              <pc:sldLayoutMk cId="3855316400" sldId="2147483677"/>
-              <ac:spMk id="15" creationId="{6AB10746-1273-02BA-C457-602DEDA7F5F4}"/>
-            </ac:spMkLst>
-          </pc:spChg>
         </pc:sldLayoutChg>
         <pc:sldLayoutChg chg="addSp delSp modSp add mod modTransition">
           <pc:chgData name="Sam Khalil" userId="82cd1ec2-6208-465b-9d4d-40ce8f0cbf96" providerId="ADAL" clId="{651B6F30-EC96-2340-AD4B-07A6B9855D0C}" dt="2025-07-21T08:07:22.700" v="2197"/>
@@ -998,13 +890,117 @@
   </pc:docChgLst>
   <pc:docChgLst>
     <pc:chgData name="Sam Khalil" userId="82cd1ec2-6208-465b-9d4d-40ce8f0cbf96" providerId="ADAL" clId="{EDFF173F-DF9C-D14E-964C-429E56C8376C}"/>
-    <pc:docChg chg="modMainMaster">
-      <pc:chgData name="Sam Khalil" userId="82cd1ec2-6208-465b-9d4d-40ce8f0cbf96" providerId="ADAL" clId="{EDFF173F-DF9C-D14E-964C-429E56C8376C}" dt="2025-08-13T18:27:27.059" v="1" actId="962"/>
+    <pc:docChg chg="undo custSel addSld delSld modSld modMainMaster">
+      <pc:chgData name="Sam Khalil" userId="82cd1ec2-6208-465b-9d4d-40ce8f0cbf96" providerId="ADAL" clId="{EDFF173F-DF9C-D14E-964C-429E56C8376C}" dt="2025-08-18T20:03:08.967" v="34" actId="478"/>
       <pc:docMkLst>
         <pc:docMk/>
       </pc:docMkLst>
+      <pc:sldChg chg="new del">
+        <pc:chgData name="Sam Khalil" userId="82cd1ec2-6208-465b-9d4d-40ce8f0cbf96" providerId="ADAL" clId="{EDFF173F-DF9C-D14E-964C-429E56C8376C}" dt="2025-08-18T19:50:55.892" v="16" actId="2696"/>
+        <pc:sldMkLst>
+          <pc:docMk/>
+          <pc:sldMk cId="1123278128" sldId="256"/>
+        </pc:sldMkLst>
+      </pc:sldChg>
+      <pc:sldChg chg="new del">
+        <pc:chgData name="Sam Khalil" userId="82cd1ec2-6208-465b-9d4d-40ce8f0cbf96" providerId="ADAL" clId="{EDFF173F-DF9C-D14E-964C-429E56C8376C}" dt="2025-08-18T19:51:52.639" v="31" actId="2696"/>
+        <pc:sldMkLst>
+          <pc:docMk/>
+          <pc:sldMk cId="2364411286" sldId="256"/>
+        </pc:sldMkLst>
+      </pc:sldChg>
+      <pc:sldChg chg="new del">
+        <pc:chgData name="Sam Khalil" userId="82cd1ec2-6208-465b-9d4d-40ce8f0cbf96" providerId="ADAL" clId="{EDFF173F-DF9C-D14E-964C-429E56C8376C}" dt="2025-08-18T19:51:02.265" v="21" actId="2696"/>
+        <pc:sldMkLst>
+          <pc:docMk/>
+          <pc:sldMk cId="2478153773" sldId="256"/>
+        </pc:sldMkLst>
+      </pc:sldChg>
+      <pc:sldChg chg="new del">
+        <pc:chgData name="Sam Khalil" userId="82cd1ec2-6208-465b-9d4d-40ce8f0cbf96" providerId="ADAL" clId="{EDFF173F-DF9C-D14E-964C-429E56C8376C}" dt="2025-08-18T19:48:30.753" v="7" actId="2696"/>
+        <pc:sldMkLst>
+          <pc:docMk/>
+          <pc:sldMk cId="4135296527" sldId="256"/>
+        </pc:sldMkLst>
+      </pc:sldChg>
+      <pc:sldChg chg="new del">
+        <pc:chgData name="Sam Khalil" userId="82cd1ec2-6208-465b-9d4d-40ce8f0cbf96" providerId="ADAL" clId="{EDFF173F-DF9C-D14E-964C-429E56C8376C}" dt="2025-08-18T19:51:01.593" v="20" actId="2696"/>
+        <pc:sldMkLst>
+          <pc:docMk/>
+          <pc:sldMk cId="538647484" sldId="257"/>
+        </pc:sldMkLst>
+      </pc:sldChg>
+      <pc:sldChg chg="new del">
+        <pc:chgData name="Sam Khalil" userId="82cd1ec2-6208-465b-9d4d-40ce8f0cbf96" providerId="ADAL" clId="{EDFF173F-DF9C-D14E-964C-429E56C8376C}" dt="2025-08-18T19:50:54.986" v="14" actId="2696"/>
+        <pc:sldMkLst>
+          <pc:docMk/>
+          <pc:sldMk cId="3443912578" sldId="257"/>
+        </pc:sldMkLst>
+      </pc:sldChg>
+      <pc:sldChg chg="new add del">
+        <pc:chgData name="Sam Khalil" userId="82cd1ec2-6208-465b-9d4d-40ce8f0cbf96" providerId="ADAL" clId="{EDFF173F-DF9C-D14E-964C-429E56C8376C}" dt="2025-08-18T19:51:13.371" v="24" actId="2696"/>
+        <pc:sldMkLst>
+          <pc:docMk/>
+          <pc:sldMk cId="502636193" sldId="258"/>
+        </pc:sldMkLst>
+      </pc:sldChg>
+      <pc:sldChg chg="addSp delSp modSp new del mod modClrScheme chgLayout">
+        <pc:chgData name="Sam Khalil" userId="82cd1ec2-6208-465b-9d4d-40ce8f0cbf96" providerId="ADAL" clId="{EDFF173F-DF9C-D14E-964C-429E56C8376C}" dt="2025-08-18T19:50:55.110" v="15" actId="2696"/>
+        <pc:sldMkLst>
+          <pc:docMk/>
+          <pc:sldMk cId="2606830780" sldId="258"/>
+        </pc:sldMkLst>
+        <pc:spChg chg="del mod ord">
+          <ac:chgData name="Sam Khalil" userId="82cd1ec2-6208-465b-9d4d-40ce8f0cbf96" providerId="ADAL" clId="{EDFF173F-DF9C-D14E-964C-429E56C8376C}" dt="2025-08-18T19:48:45.682" v="11" actId="700"/>
+          <ac:spMkLst>
+            <pc:docMk/>
+            <pc:sldMk cId="2606830780" sldId="258"/>
+            <ac:spMk id="2" creationId="{E1E10412-FEAF-2783-BD99-BF99E94294E1}"/>
+          </ac:spMkLst>
+        </pc:spChg>
+        <pc:spChg chg="del">
+          <ac:chgData name="Sam Khalil" userId="82cd1ec2-6208-465b-9d4d-40ce8f0cbf96" providerId="ADAL" clId="{EDFF173F-DF9C-D14E-964C-429E56C8376C}" dt="2025-08-18T19:48:45.682" v="11" actId="700"/>
+          <ac:spMkLst>
+            <pc:docMk/>
+            <pc:sldMk cId="2606830780" sldId="258"/>
+            <ac:spMk id="3" creationId="{28A2B804-505B-9DEE-D805-66A2C9935BBB}"/>
+          </ac:spMkLst>
+        </pc:spChg>
+        <pc:spChg chg="del">
+          <ac:chgData name="Sam Khalil" userId="82cd1ec2-6208-465b-9d4d-40ce8f0cbf96" providerId="ADAL" clId="{EDFF173F-DF9C-D14E-964C-429E56C8376C}" dt="2025-08-18T19:48:45.682" v="11" actId="700"/>
+          <ac:spMkLst>
+            <pc:docMk/>
+            <pc:sldMk cId="2606830780" sldId="258"/>
+            <ac:spMk id="4" creationId="{89BF648E-A58E-622E-1CFA-30302C30DD07}"/>
+          </ac:spMkLst>
+        </pc:spChg>
+        <pc:spChg chg="del">
+          <ac:chgData name="Sam Khalil" userId="82cd1ec2-6208-465b-9d4d-40ce8f0cbf96" providerId="ADAL" clId="{EDFF173F-DF9C-D14E-964C-429E56C8376C}" dt="2025-08-18T19:48:45.682" v="11" actId="700"/>
+          <ac:spMkLst>
+            <pc:docMk/>
+            <pc:sldMk cId="2606830780" sldId="258"/>
+            <ac:spMk id="5" creationId="{7EE067C2-7A96-E9EC-9437-16F99C608A07}"/>
+          </ac:spMkLst>
+        </pc:spChg>
+        <pc:spChg chg="add mod ord">
+          <ac:chgData name="Sam Khalil" userId="82cd1ec2-6208-465b-9d4d-40ce8f0cbf96" providerId="ADAL" clId="{EDFF173F-DF9C-D14E-964C-429E56C8376C}" dt="2025-08-18T19:48:45.682" v="11" actId="700"/>
+          <ac:spMkLst>
+            <pc:docMk/>
+            <pc:sldMk cId="2606830780" sldId="258"/>
+            <ac:spMk id="6" creationId="{7E2071A8-E0E4-E1ED-A36E-4840230E65F2}"/>
+          </ac:spMkLst>
+        </pc:spChg>
+        <pc:spChg chg="add mod ord">
+          <ac:chgData name="Sam Khalil" userId="82cd1ec2-6208-465b-9d4d-40ce8f0cbf96" providerId="ADAL" clId="{EDFF173F-DF9C-D14E-964C-429E56C8376C}" dt="2025-08-18T19:48:45.682" v="11" actId="700"/>
+          <ac:spMkLst>
+            <pc:docMk/>
+            <pc:sldMk cId="2606830780" sldId="258"/>
+            <ac:spMk id="7" creationId="{72DE0D04-8524-055C-A75E-789F998977DA}"/>
+          </ac:spMkLst>
+        </pc:spChg>
+      </pc:sldChg>
       <pc:sldMasterChg chg="modSldLayout">
-        <pc:chgData name="Sam Khalil" userId="82cd1ec2-6208-465b-9d4d-40ce8f0cbf96" providerId="ADAL" clId="{EDFF173F-DF9C-D14E-964C-429E56C8376C}" dt="2025-08-13T18:27:27.059" v="1" actId="962"/>
+        <pc:chgData name="Sam Khalil" userId="82cd1ec2-6208-465b-9d4d-40ce8f0cbf96" providerId="ADAL" clId="{EDFF173F-DF9C-D14E-964C-429E56C8376C}" dt="2025-08-18T20:03:08.967" v="34" actId="478"/>
         <pc:sldMasterMkLst>
           <pc:docMk/>
           <pc:sldMasterMk cId="2940896467" sldId="2147483648"/>
@@ -1032,6 +1028,58 @@
               <pc:sldMasterMk cId="2940896467" sldId="2147483648"/>
               <pc:sldLayoutMk cId="3074954578" sldId="2147483650"/>
               <ac:spMk id="5" creationId="{4286C11B-CD57-AE94-2379-3F6FBE23504C}"/>
+            </ac:spMkLst>
+          </pc:spChg>
+        </pc:sldLayoutChg>
+        <pc:sldLayoutChg chg="modSp mod">
+          <pc:chgData name="Sam Khalil" userId="82cd1ec2-6208-465b-9d4d-40ce8f0cbf96" providerId="ADAL" clId="{EDFF173F-DF9C-D14E-964C-429E56C8376C}" dt="2025-08-13T19:16:19.386" v="5"/>
+          <pc:sldLayoutMkLst>
+            <pc:docMk/>
+            <pc:sldMasterMk cId="2940896467" sldId="2147483648"/>
+            <pc:sldLayoutMk cId="3100185760" sldId="2147483667"/>
+          </pc:sldLayoutMkLst>
+          <pc:spChg chg="mod modVis">
+            <ac:chgData name="Sam Khalil" userId="82cd1ec2-6208-465b-9d4d-40ce8f0cbf96" providerId="ADAL" clId="{EDFF173F-DF9C-D14E-964C-429E56C8376C}" dt="2025-08-13T19:16:19.386" v="5"/>
+            <ac:spMkLst>
+              <pc:docMk/>
+              <pc:sldMasterMk cId="2940896467" sldId="2147483648"/>
+              <pc:sldLayoutMk cId="3100185760" sldId="2147483667"/>
+              <ac:spMk id="4" creationId="{F8567C99-F3EA-939B-081F-B8C4B329CCCE}"/>
+            </ac:spMkLst>
+          </pc:spChg>
+        </pc:sldLayoutChg>
+        <pc:sldLayoutChg chg="delSp modSp mod">
+          <pc:chgData name="Sam Khalil" userId="82cd1ec2-6208-465b-9d4d-40ce8f0cbf96" providerId="ADAL" clId="{EDFF173F-DF9C-D14E-964C-429E56C8376C}" dt="2025-08-18T20:03:08.967" v="34" actId="478"/>
+          <pc:sldLayoutMkLst>
+            <pc:docMk/>
+            <pc:sldMasterMk cId="2940896467" sldId="2147483648"/>
+            <pc:sldLayoutMk cId="976521419" sldId="2147483671"/>
+          </pc:sldLayoutMkLst>
+          <pc:spChg chg="del">
+            <ac:chgData name="Sam Khalil" userId="82cd1ec2-6208-465b-9d4d-40ce8f0cbf96" providerId="ADAL" clId="{EDFF173F-DF9C-D14E-964C-429E56C8376C}" dt="2025-08-18T20:03:08.967" v="34" actId="478"/>
+            <ac:spMkLst>
+              <pc:docMk/>
+              <pc:sldMasterMk cId="2940896467" sldId="2147483648"/>
+              <pc:sldLayoutMk cId="976521419" sldId="2147483671"/>
+              <ac:spMk id="2" creationId="{451BA699-B22C-5269-513E-35DC959DE690}"/>
+            </ac:spMkLst>
+          </pc:spChg>
+          <pc:spChg chg="mod">
+            <ac:chgData name="Sam Khalil" userId="82cd1ec2-6208-465b-9d4d-40ce8f0cbf96" providerId="ADAL" clId="{EDFF173F-DF9C-D14E-964C-429E56C8376C}" dt="2025-08-18T19:51:21.115" v="26" actId="207"/>
+            <ac:spMkLst>
+              <pc:docMk/>
+              <pc:sldMasterMk cId="2940896467" sldId="2147483648"/>
+              <pc:sldLayoutMk cId="976521419" sldId="2147483671"/>
+              <ac:spMk id="5" creationId="{CBE66CB9-C849-3A55-3368-6C1666C50D4F}"/>
+            </ac:spMkLst>
+          </pc:spChg>
+          <pc:spChg chg="mod">
+            <ac:chgData name="Sam Khalil" userId="82cd1ec2-6208-465b-9d4d-40ce8f0cbf96" providerId="ADAL" clId="{EDFF173F-DF9C-D14E-964C-429E56C8376C}" dt="2025-08-18T19:52:00.502" v="33" actId="20577"/>
+            <ac:spMkLst>
+              <pc:docMk/>
+              <pc:sldMasterMk cId="2940896467" sldId="2147483648"/>
+              <pc:sldLayoutMk cId="976521419" sldId="2147483671"/>
+              <ac:spMk id="9" creationId="{755D5765-4853-2CD1-FD28-234442F507BD}"/>
             </ac:spMkLst>
           </pc:spChg>
         </pc:sldLayoutChg>
@@ -1135,7 +1183,7 @@
           <a:p>
             <a:fld id="{D2339670-67E6-CD42-B7B2-F285F1108ED9}" type="datetimeFigureOut">
               <a:rPr lang="en-US" smtClean="0"/>
-              <a:t>8/13/25</a:t>
+              <a:t>8/18/25</a:t>
             </a:fld>
             <a:endParaRPr lang="en-US"/>
           </a:p>
@@ -1311,7 +1359,7 @@
           </a:lstStyle>
           <a:p>
             <a:fld id="{1E521F2A-B11E-40E0-8F26-7CD21B55A12D}" type="datetimeFigureOut">
-              <a:t>8/13/25</a:t>
+              <a:t>8/18/25</a:t>
             </a:fld>
             <a:endParaRPr lang="en-GB"/>
           </a:p>
@@ -4386,8 +4434,21 @@
         <p:txBody>
           <a:bodyPr/>
           <a:lstStyle>
-            <a:lvl1pPr marL="0" indent="0">
+            <a:lvl1pPr marL="0" marR="0" indent="0" algn="l" defTabSz="914400" rtl="0" eaLnBrk="1" fontAlgn="auto" latinLnBrk="0" hangingPunct="1">
+              <a:lnSpc>
+                <a:spcPct val="90000"/>
+              </a:lnSpc>
+              <a:spcBef>
+                <a:spcPts val="1000"/>
+              </a:spcBef>
+              <a:spcAft>
+                <a:spcPts val="0"/>
+              </a:spcAft>
+              <a:buClrTx/>
+              <a:buSzTx/>
+              <a:buFont typeface="Arial" panose="020B0604020202020204" pitchFamily="34" charset="0"/>
               <a:buNone/>
+              <a:tabLst/>
               <a:defRPr sz="2000"/>
             </a:lvl1pPr>
             <a:lvl2pPr marL="457200" indent="0">
@@ -4400,52 +4461,6 @@
             <a:r>
               <a:rPr lang="en-US" dirty="0"/>
               <a:t>Presenter name and title</a:t>
-            </a:r>
-          </a:p>
-        </p:txBody>
-      </p:sp>
-      <p:sp>
-        <p:nvSpPr>
-          <p:cNvPr id="2" name="Random Animal Name here">
-            <a:extLst>
-              <a:ext uri="{FF2B5EF4-FFF2-40B4-BE49-F238E27FC236}">
-                <a16:creationId xmlns:a16="http://schemas.microsoft.com/office/drawing/2014/main" id="{451BA699-B22C-5269-513E-35DC959DE690}"/>
-              </a:ext>
-            </a:extLst>
-          </p:cNvPr>
-          <p:cNvSpPr>
-            <a:spLocks noGrp="1"/>
-          </p:cNvSpPr>
-          <p:nvPr>
-            <p:ph type="body" sz="quarter" idx="14" hasCustomPrompt="1"/>
-          </p:nvPr>
-        </p:nvSpPr>
-        <p:spPr>
-          <a:xfrm>
-            <a:off x="8451056" y="4483455"/>
-            <a:ext cx="3271044" cy="914400"/>
-          </a:xfrm>
-          <a:prstGeom prst="rect">
-            <a:avLst/>
-          </a:prstGeom>
-        </p:spPr>
-        <p:txBody>
-          <a:bodyPr/>
-          <a:lstStyle>
-            <a:lvl1pPr marL="0" indent="0">
-              <a:buNone/>
-              <a:defRPr sz="2000"/>
-            </a:lvl1pPr>
-            <a:lvl2pPr marL="457200" indent="0">
-              <a:buNone/>
-              <a:defRPr/>
-            </a:lvl2pPr>
-          </a:lstStyle>
-          <a:p>
-            <a:pPr lvl="0"/>
-            <a:r>
-              <a:rPr lang="en-US" dirty="0"/>
-              <a:t>A random animal name here</a:t>
             </a:r>
           </a:p>
         </p:txBody>
@@ -5087,7 +5102,9 @@
               </a:ext>
             </a:extLst>
           </p:cNvPr>
-          <p:cNvSpPr/>
+          <p:cNvSpPr>
+            <a:spLocks/>
+          </p:cNvSpPr>
           <p:nvPr userDrawn="1"/>
         </p:nvSpPr>
         <p:spPr>
@@ -9287,16 +9304,16 @@
 <file path=customXml/itemProps2.xml><?xml version="1.0" encoding="utf-8"?>
 <ds:datastoreItem xmlns:ds="http://schemas.openxmlformats.org/officeDocument/2006/customXml" ds:itemID="{E18F5EE7-65DF-41C5-963C-25B6B377F939}">
   <ds:schemaRefs>
+    <ds:schemaRef ds:uri="http://schemas.microsoft.com/office/2006/metadata/properties"/>
+    <ds:schemaRef ds:uri="http://purl.org/dc/terms/"/>
     <ds:schemaRef ds:uri="http://schemas.microsoft.com/office/infopath/2007/PartnerControls"/>
+    <ds:schemaRef ds:uri="http://purl.org/dc/dcmitype/"/>
+    <ds:schemaRef ds:uri="http://purl.org/dc/elements/1.1/"/>
+    <ds:schemaRef ds:uri="bdfda862-7558-4f4e-99f8-648970d7935e"/>
+    <ds:schemaRef ds:uri="http://www.w3.org/XML/1998/namespace"/>
+    <ds:schemaRef ds:uri="http://schemas.microsoft.com/office/2006/documentManagement/types"/>
+    <ds:schemaRef ds:uri="http://schemas.openxmlformats.org/package/2006/metadata/core-properties"/>
     <ds:schemaRef ds:uri="2bdccfd7-ed75-47c4-ae3e-45ba8291135b"/>
-    <ds:schemaRef ds:uri="http://purl.org/dc/terms/"/>
-    <ds:schemaRef ds:uri="http://www.w3.org/XML/1998/namespace"/>
-    <ds:schemaRef ds:uri="http://schemas.microsoft.com/office/2006/metadata/properties"/>
-    <ds:schemaRef ds:uri="http://schemas.microsoft.com/office/2006/documentManagement/types"/>
-    <ds:schemaRef ds:uri="bdfda862-7558-4f4e-99f8-648970d7935e"/>
-    <ds:schemaRef ds:uri="http://purl.org/dc/elements/1.1/"/>
-    <ds:schemaRef ds:uri="http://schemas.openxmlformats.org/package/2006/metadata/core-properties"/>
-    <ds:schemaRef ds:uri="http://purl.org/dc/dcmitype/"/>
   </ds:schemaRefs>
 </ds:datastoreItem>
 </file>

</xml_diff>

<commit_message>
Improved HTML generation prompts
</commit_message>
<xml_diff>
--- a/templates/ekona_slides_template_new/ekona_slides_template_new.pptx
+++ b/templates/ekona_slides_template_new/ekona_slides_template_new.pptx
@@ -121,7 +121,7 @@
 <file path=ppt/revisionInfo.xml><?xml version="1.0" encoding="utf-8"?>
 <p1510:revInfo xmlns:a="http://schemas.openxmlformats.org/drawingml/2006/main" xmlns:r="http://schemas.openxmlformats.org/officeDocument/2006/relationships" xmlns:p1510="http://schemas.microsoft.com/office/powerpoint/2015/10/main">
   <p1510:revLst>
-    <p1510:client id="{EDFF173F-DF9C-D14E-964C-429E56C8376C}" v="7" dt="2025-08-18T19:51:33.294"/>
+    <p1510:client id="{EDFF173F-DF9C-D14E-964C-429E56C8376C}" v="9" dt="2025-08-18T22:25:01.898"/>
   </p1510:revLst>
 </p1510:revInfo>
 </file>
@@ -891,7 +891,7 @@
   <pc:docChgLst>
     <pc:chgData name="Sam Khalil" userId="82cd1ec2-6208-465b-9d4d-40ce8f0cbf96" providerId="ADAL" clId="{EDFF173F-DF9C-D14E-964C-429E56C8376C}"/>
     <pc:docChg chg="undo custSel addSld delSld modSld modMainMaster">
-      <pc:chgData name="Sam Khalil" userId="82cd1ec2-6208-465b-9d4d-40ce8f0cbf96" providerId="ADAL" clId="{EDFF173F-DF9C-D14E-964C-429E56C8376C}" dt="2025-08-18T20:03:08.967" v="34" actId="478"/>
+      <pc:chgData name="Sam Khalil" userId="82cd1ec2-6208-465b-9d4d-40ce8f0cbf96" providerId="ADAL" clId="{EDFF173F-DF9C-D14E-964C-429E56C8376C}" dt="2025-08-18T22:25:01.898" v="36" actId="948"/>
       <pc:docMkLst>
         <pc:docMk/>
       </pc:docMkLst>
@@ -1000,7 +1000,7 @@
         </pc:spChg>
       </pc:sldChg>
       <pc:sldMasterChg chg="modSldLayout">
-        <pc:chgData name="Sam Khalil" userId="82cd1ec2-6208-465b-9d4d-40ce8f0cbf96" providerId="ADAL" clId="{EDFF173F-DF9C-D14E-964C-429E56C8376C}" dt="2025-08-18T20:03:08.967" v="34" actId="478"/>
+        <pc:chgData name="Sam Khalil" userId="82cd1ec2-6208-465b-9d4d-40ce8f0cbf96" providerId="ADAL" clId="{EDFF173F-DF9C-D14E-964C-429E56C8376C}" dt="2025-08-18T22:25:01.898" v="36" actId="948"/>
         <pc:sldMasterMkLst>
           <pc:docMk/>
           <pc:sldMasterMk cId="2940896467" sldId="2147483648"/>
@@ -1032,12 +1032,21 @@
           </pc:spChg>
         </pc:sldLayoutChg>
         <pc:sldLayoutChg chg="modSp mod">
-          <pc:chgData name="Sam Khalil" userId="82cd1ec2-6208-465b-9d4d-40ce8f0cbf96" providerId="ADAL" clId="{EDFF173F-DF9C-D14E-964C-429E56C8376C}" dt="2025-08-13T19:16:19.386" v="5"/>
+          <pc:chgData name="Sam Khalil" userId="82cd1ec2-6208-465b-9d4d-40ce8f0cbf96" providerId="ADAL" clId="{EDFF173F-DF9C-D14E-964C-429E56C8376C}" dt="2025-08-18T22:25:01.898" v="36" actId="948"/>
           <pc:sldLayoutMkLst>
             <pc:docMk/>
             <pc:sldMasterMk cId="2940896467" sldId="2147483648"/>
             <pc:sldLayoutMk cId="3100185760" sldId="2147483667"/>
           </pc:sldLayoutMkLst>
+          <pc:spChg chg="mod">
+            <ac:chgData name="Sam Khalil" userId="82cd1ec2-6208-465b-9d4d-40ce8f0cbf96" providerId="ADAL" clId="{EDFF173F-DF9C-D14E-964C-429E56C8376C}" dt="2025-08-18T22:25:01.898" v="36" actId="948"/>
+            <ac:spMkLst>
+              <pc:docMk/>
+              <pc:sldMasterMk cId="2940896467" sldId="2147483648"/>
+              <pc:sldLayoutMk cId="3100185760" sldId="2147483667"/>
+              <ac:spMk id="3" creationId="{8A6FC6F2-80B4-49A7-9448-33FE2DF0E967}"/>
+            </ac:spMkLst>
+          </pc:spChg>
           <pc:spChg chg="mod modVis">
             <ac:chgData name="Sam Khalil" userId="82cd1ec2-6208-465b-9d4d-40ce8f0cbf96" providerId="ADAL" clId="{EDFF173F-DF9C-D14E-964C-429E56C8376C}" dt="2025-08-13T19:16:19.386" v="5"/>
             <ac:spMkLst>
@@ -1183,7 +1192,7 @@
           <a:p>
             <a:fld id="{D2339670-67E6-CD42-B7B2-F285F1108ED9}" type="datetimeFigureOut">
               <a:rPr lang="en-US" smtClean="0"/>
-              <a:t>8/18/25</a:t>
+              <a:t>8/19/25</a:t>
             </a:fld>
             <a:endParaRPr lang="en-US"/>
           </a:p>
@@ -1359,7 +1368,7 @@
           </a:lstStyle>
           <a:p>
             <a:fld id="{1E521F2A-B11E-40E0-8F26-7CD21B55A12D}" type="datetimeFigureOut">
-              <a:t>8/18/25</a:t>
+              <a:t>8/19/25</a:t>
             </a:fld>
             <a:endParaRPr lang="en-GB"/>
           </a:p>
@@ -9056,6 +9065,26 @@
 </file>
 
 <file path=customXml/item1.xml><?xml version="1.0" encoding="utf-8"?>
+<?mso-contentType ?>
+<FormTemplates xmlns="http://schemas.microsoft.com/sharepoint/v3/contenttype/forms">
+  <Display>DocumentLibraryForm</Display>
+  <Edit>DocumentLibraryForm</Edit>
+  <New>DocumentLibraryForm</New>
+</FormTemplates>
+</file>
+
+<file path=customXml/item2.xml><?xml version="1.0" encoding="utf-8"?>
+<p:properties xmlns:p="http://schemas.microsoft.com/office/2006/metadata/properties" xmlns:xsi="http://www.w3.org/2001/XMLSchema-instance" xmlns:pc="http://schemas.microsoft.com/office/infopath/2007/PartnerControls">
+  <documentManagement>
+    <TaxCatchAll xmlns="2bdccfd7-ed75-47c4-ae3e-45ba8291135b" xsi:nil="true"/>
+    <lcf76f155ced4ddcb4097134ff3c332f xmlns="bdfda862-7558-4f4e-99f8-648970d7935e">
+      <Terms xmlns="http://schemas.microsoft.com/office/infopath/2007/PartnerControls"/>
+    </lcf76f155ced4ddcb4097134ff3c332f>
+  </documentManagement>
+</p:properties>
+</file>
+
+<file path=customXml/item3.xml><?xml version="1.0" encoding="utf-8"?>
 <ct:contentTypeSchema xmlns:ct="http://schemas.microsoft.com/office/2006/metadata/contentType" xmlns:ma="http://schemas.microsoft.com/office/2006/metadata/properties/metaAttributes" ct:_="" ma:_="" ma:contentTypeName="Document" ma:contentTypeID="0x0101009D55CCFAD34A484FAC43376D580F7497" ma:contentTypeVersion="13" ma:contentTypeDescription="Create a new document." ma:contentTypeScope="" ma:versionID="20fcfebd8cb07aba400aa359cb6a137d">
   <xsd:schema xmlns:xsd="http://www.w3.org/2001/XMLSchema" xmlns:xs="http://www.w3.org/2001/XMLSchema" xmlns:p="http://schemas.microsoft.com/office/2006/metadata/properties" xmlns:ns2="bdfda862-7558-4f4e-99f8-648970d7935e" xmlns:ns3="2bdccfd7-ed75-47c4-ae3e-45ba8291135b" targetNamespace="http://schemas.microsoft.com/office/2006/metadata/properties" ma:root="true" ma:fieldsID="e7232410060904e04ccc6d86ba125b69" ns2:_="" ns3:_="">
     <xsd:import namespace="bdfda862-7558-4f4e-99f8-648970d7935e"/>
@@ -9262,27 +9291,32 @@
 </ct:contentTypeSchema>
 </file>
 
-<file path=customXml/item2.xml><?xml version="1.0" encoding="utf-8"?>
-<p:properties xmlns:p="http://schemas.microsoft.com/office/2006/metadata/properties" xmlns:xsi="http://www.w3.org/2001/XMLSchema-instance" xmlns:pc="http://schemas.microsoft.com/office/infopath/2007/PartnerControls">
-  <documentManagement>
-    <TaxCatchAll xmlns="2bdccfd7-ed75-47c4-ae3e-45ba8291135b" xsi:nil="true"/>
-    <lcf76f155ced4ddcb4097134ff3c332f xmlns="bdfda862-7558-4f4e-99f8-648970d7935e">
-      <Terms xmlns="http://schemas.microsoft.com/office/infopath/2007/PartnerControls"/>
-    </lcf76f155ced4ddcb4097134ff3c332f>
-  </documentManagement>
-</p:properties>
+<file path=customXml/itemProps1.xml><?xml version="1.0" encoding="utf-8"?>
+<ds:datastoreItem xmlns:ds="http://schemas.openxmlformats.org/officeDocument/2006/customXml" ds:itemID="{C2B4E4C2-7A23-4EC8-AE63-F75F63DE72BE}">
+  <ds:schemaRefs>
+    <ds:schemaRef ds:uri="http://schemas.microsoft.com/sharepoint/v3/contenttype/forms"/>
+  </ds:schemaRefs>
+</ds:datastoreItem>
 </file>
 
-<file path=customXml/item3.xml><?xml version="1.0" encoding="utf-8"?>
-<?mso-contentType ?>
-<FormTemplates xmlns="http://schemas.microsoft.com/sharepoint/v3/contenttype/forms">
-  <Display>DocumentLibraryForm</Display>
-  <Edit>DocumentLibraryForm</Edit>
-  <New>DocumentLibraryForm</New>
-</FormTemplates>
+<file path=customXml/itemProps2.xml><?xml version="1.0" encoding="utf-8"?>
+<ds:datastoreItem xmlns:ds="http://schemas.openxmlformats.org/officeDocument/2006/customXml" ds:itemID="{E18F5EE7-65DF-41C5-963C-25B6B377F939}">
+  <ds:schemaRefs>
+    <ds:schemaRef ds:uri="http://schemas.microsoft.com/office/infopath/2007/PartnerControls"/>
+    <ds:schemaRef ds:uri="bdfda862-7558-4f4e-99f8-648970d7935e"/>
+    <ds:schemaRef ds:uri="http://purl.org/dc/dcmitype/"/>
+    <ds:schemaRef ds:uri="http://schemas.microsoft.com/office/2006/documentManagement/types"/>
+    <ds:schemaRef ds:uri="http://purl.org/dc/elements/1.1/"/>
+    <ds:schemaRef ds:uri="http://purl.org/dc/terms/"/>
+    <ds:schemaRef ds:uri="http://schemas.microsoft.com/office/2006/metadata/properties"/>
+    <ds:schemaRef ds:uri="http://schemas.openxmlformats.org/package/2006/metadata/core-properties"/>
+    <ds:schemaRef ds:uri="2bdccfd7-ed75-47c4-ae3e-45ba8291135b"/>
+    <ds:schemaRef ds:uri="http://www.w3.org/XML/1998/namespace"/>
+  </ds:schemaRefs>
+</ds:datastoreItem>
 </file>
 
-<file path=customXml/itemProps1.xml><?xml version="1.0" encoding="utf-8"?>
+<file path=customXml/itemProps3.xml><?xml version="1.0" encoding="utf-8"?>
 <ds:datastoreItem xmlns:ds="http://schemas.openxmlformats.org/officeDocument/2006/customXml" ds:itemID="{26AA38A5-B176-4017-B3F9-F5D611C74B49}">
   <ds:schemaRefs>
     <ds:schemaRef ds:uri="http://schemas.microsoft.com/office/2006/metadata/contentType"/>
@@ -9299,29 +9333,4 @@
     <ds:schemaRef ds:uri="http://schemas.microsoft.com/internal/obd"/>
   </ds:schemaRefs>
 </ds:datastoreItem>
-</file>
-
-<file path=customXml/itemProps2.xml><?xml version="1.0" encoding="utf-8"?>
-<ds:datastoreItem xmlns:ds="http://schemas.openxmlformats.org/officeDocument/2006/customXml" ds:itemID="{E18F5EE7-65DF-41C5-963C-25B6B377F939}">
-  <ds:schemaRefs>
-    <ds:schemaRef ds:uri="http://schemas.microsoft.com/office/2006/metadata/properties"/>
-    <ds:schemaRef ds:uri="http://purl.org/dc/terms/"/>
-    <ds:schemaRef ds:uri="http://schemas.microsoft.com/office/infopath/2007/PartnerControls"/>
-    <ds:schemaRef ds:uri="http://purl.org/dc/dcmitype/"/>
-    <ds:schemaRef ds:uri="http://purl.org/dc/elements/1.1/"/>
-    <ds:schemaRef ds:uri="bdfda862-7558-4f4e-99f8-648970d7935e"/>
-    <ds:schemaRef ds:uri="http://www.w3.org/XML/1998/namespace"/>
-    <ds:schemaRef ds:uri="http://schemas.microsoft.com/office/2006/documentManagement/types"/>
-    <ds:schemaRef ds:uri="http://schemas.openxmlformats.org/package/2006/metadata/core-properties"/>
-    <ds:schemaRef ds:uri="2bdccfd7-ed75-47c4-ae3e-45ba8291135b"/>
-  </ds:schemaRefs>
-</ds:datastoreItem>
-</file>
-
-<file path=customXml/itemProps3.xml><?xml version="1.0" encoding="utf-8"?>
-<ds:datastoreItem xmlns:ds="http://schemas.openxmlformats.org/officeDocument/2006/customXml" ds:itemID="{C2B4E4C2-7A23-4EC8-AE63-F75F63DE72BE}">
-  <ds:schemaRefs>
-    <ds:schemaRef ds:uri="http://schemas.microsoft.com/sharepoint/v3/contenttype/forms"/>
-  </ds:schemaRefs>
-</ds:datastoreItem>
 </file>
</xml_diff>